<commit_message>
prototype and latest version of Project 1 report
</commit_message>
<xml_diff>
--- a/Presentation.pptx
+++ b/Presentation.pptx
@@ -5,7 +5,7 @@
     <p:sldMasterId id="2147483672" r:id="rId1"/>
   </p:sldMasterIdLst>
   <p:notesMasterIdLst>
-    <p:notesMasterId r:id="rId9"/>
+    <p:notesMasterId r:id="rId10"/>
   </p:notesMasterIdLst>
   <p:sldIdLst>
     <p:sldId id="256" r:id="rId2"/>
@@ -13,8 +13,9 @@
     <p:sldId id="258" r:id="rId4"/>
     <p:sldId id="259" r:id="rId5"/>
     <p:sldId id="260" r:id="rId6"/>
-    <p:sldId id="261" r:id="rId7"/>
-    <p:sldId id="262" r:id="rId8"/>
+    <p:sldId id="263" r:id="rId7"/>
+    <p:sldId id="261" r:id="rId8"/>
+    <p:sldId id="262" r:id="rId9"/>
   </p:sldIdLst>
   <p:sldSz cx="12192000" cy="6858000"/>
   <p:notesSz cx="6858000" cy="9144000"/>
@@ -203,7 +204,7 @@
           <a:p>
             <a:fld id="{F4B1C52A-EB35-452D-B38A-9407D7D2B8AD}" type="datetimeFigureOut">
               <a:rPr lang="en-IE" smtClean="0"/>
-              <a:t>01/12/2024</a:t>
+              <a:t>07/01/2025</a:t>
             </a:fld>
             <a:endParaRPr lang="en-IE"/>
           </a:p>
@@ -741,7 +742,7 @@
           <a:p>
             <a:fld id="{BA776EC6-7CCE-42A4-93A6-731DCB5BC438}" type="datetimeFigureOut">
               <a:rPr lang="en-GB" smtClean="0"/>
-              <a:t>01/12/2024</a:t>
+              <a:t>07/01/2025</a:t>
             </a:fld>
             <a:endParaRPr lang="en-GB"/>
           </a:p>
@@ -1016,7 +1017,7 @@
           <a:p>
             <a:fld id="{BA776EC6-7CCE-42A4-93A6-731DCB5BC438}" type="datetimeFigureOut">
               <a:rPr lang="en-GB" smtClean="0"/>
-              <a:t>01/12/2024</a:t>
+              <a:t>07/01/2025</a:t>
             </a:fld>
             <a:endParaRPr lang="en-GB"/>
           </a:p>
@@ -1210,7 +1211,7 @@
           <a:p>
             <a:fld id="{BA776EC6-7CCE-42A4-93A6-731DCB5BC438}" type="datetimeFigureOut">
               <a:rPr lang="en-GB" smtClean="0"/>
-              <a:t>01/12/2024</a:t>
+              <a:t>07/01/2025</a:t>
             </a:fld>
             <a:endParaRPr lang="en-GB"/>
           </a:p>
@@ -1483,7 +1484,7 @@
           <a:p>
             <a:fld id="{BA776EC6-7CCE-42A4-93A6-731DCB5BC438}" type="datetimeFigureOut">
               <a:rPr lang="en-GB" smtClean="0"/>
-              <a:t>01/12/2024</a:t>
+              <a:t>07/01/2025</a:t>
             </a:fld>
             <a:endParaRPr lang="en-GB"/>
           </a:p>
@@ -1824,7 +1825,7 @@
           <a:p>
             <a:fld id="{BA776EC6-7CCE-42A4-93A6-731DCB5BC438}" type="datetimeFigureOut">
               <a:rPr lang="en-GB" smtClean="0"/>
-              <a:t>01/12/2024</a:t>
+              <a:t>07/01/2025</a:t>
             </a:fld>
             <a:endParaRPr lang="en-GB"/>
           </a:p>
@@ -2447,7 +2448,7 @@
           <a:p>
             <a:fld id="{BA776EC6-7CCE-42A4-93A6-731DCB5BC438}" type="datetimeFigureOut">
               <a:rPr lang="en-GB" smtClean="0"/>
-              <a:t>01/12/2024</a:t>
+              <a:t>07/01/2025</a:t>
             </a:fld>
             <a:endParaRPr lang="en-GB"/>
           </a:p>
@@ -3307,7 +3308,7 @@
           <a:p>
             <a:fld id="{BA776EC6-7CCE-42A4-93A6-731DCB5BC438}" type="datetimeFigureOut">
               <a:rPr lang="en-GB" smtClean="0"/>
-              <a:t>01/12/2024</a:t>
+              <a:t>07/01/2025</a:t>
             </a:fld>
             <a:endParaRPr lang="en-GB"/>
           </a:p>
@@ -3477,7 +3478,7 @@
           <a:p>
             <a:fld id="{BA776EC6-7CCE-42A4-93A6-731DCB5BC438}" type="datetimeFigureOut">
               <a:rPr lang="en-GB" smtClean="0"/>
-              <a:t>01/12/2024</a:t>
+              <a:t>07/01/2025</a:t>
             </a:fld>
             <a:endParaRPr lang="en-GB"/>
           </a:p>
@@ -3657,7 +3658,7 @@
           <a:p>
             <a:fld id="{BA776EC6-7CCE-42A4-93A6-731DCB5BC438}" type="datetimeFigureOut">
               <a:rPr lang="en-GB" smtClean="0"/>
-              <a:t>01/12/2024</a:t>
+              <a:t>07/01/2025</a:t>
             </a:fld>
             <a:endParaRPr lang="en-GB"/>
           </a:p>
@@ -3827,7 +3828,7 @@
           <a:p>
             <a:fld id="{BA776EC6-7CCE-42A4-93A6-731DCB5BC438}" type="datetimeFigureOut">
               <a:rPr lang="en-GB" smtClean="0"/>
-              <a:t>01/12/2024</a:t>
+              <a:t>07/01/2025</a:t>
             </a:fld>
             <a:endParaRPr lang="en-GB"/>
           </a:p>
@@ -4074,7 +4075,7 @@
           <a:p>
             <a:fld id="{BA776EC6-7CCE-42A4-93A6-731DCB5BC438}" type="datetimeFigureOut">
               <a:rPr lang="en-GB" smtClean="0"/>
-              <a:t>01/12/2024</a:t>
+              <a:t>07/01/2025</a:t>
             </a:fld>
             <a:endParaRPr lang="en-GB"/>
           </a:p>
@@ -4366,7 +4367,7 @@
           <a:p>
             <a:fld id="{BA776EC6-7CCE-42A4-93A6-731DCB5BC438}" type="datetimeFigureOut">
               <a:rPr lang="en-GB" smtClean="0"/>
-              <a:t>01/12/2024</a:t>
+              <a:t>07/01/2025</a:t>
             </a:fld>
             <a:endParaRPr lang="en-GB"/>
           </a:p>
@@ -4810,7 +4811,7 @@
           <a:p>
             <a:fld id="{BA776EC6-7CCE-42A4-93A6-731DCB5BC438}" type="datetimeFigureOut">
               <a:rPr lang="en-GB" smtClean="0"/>
-              <a:t>01/12/2024</a:t>
+              <a:t>07/01/2025</a:t>
             </a:fld>
             <a:endParaRPr lang="en-GB"/>
           </a:p>
@@ -4928,7 +4929,7 @@
           <a:p>
             <a:fld id="{BA776EC6-7CCE-42A4-93A6-731DCB5BC438}" type="datetimeFigureOut">
               <a:rPr lang="en-GB" smtClean="0"/>
-              <a:t>01/12/2024</a:t>
+              <a:t>07/01/2025</a:t>
             </a:fld>
             <a:endParaRPr lang="en-GB"/>
           </a:p>
@@ -5023,7 +5024,7 @@
           <a:p>
             <a:fld id="{BA776EC6-7CCE-42A4-93A6-731DCB5BC438}" type="datetimeFigureOut">
               <a:rPr lang="en-GB" smtClean="0"/>
-              <a:t>01/12/2024</a:t>
+              <a:t>07/01/2025</a:t>
             </a:fld>
             <a:endParaRPr lang="en-GB"/>
           </a:p>
@@ -5302,7 +5303,7 @@
           <a:p>
             <a:fld id="{BA776EC6-7CCE-42A4-93A6-731DCB5BC438}" type="datetimeFigureOut">
               <a:rPr lang="en-GB" smtClean="0"/>
-              <a:t>01/12/2024</a:t>
+              <a:t>07/01/2025</a:t>
             </a:fld>
             <a:endParaRPr lang="en-GB"/>
           </a:p>
@@ -5577,7 +5578,7 @@
           <a:p>
             <a:fld id="{BA776EC6-7CCE-42A4-93A6-731DCB5BC438}" type="datetimeFigureOut">
               <a:rPr lang="en-GB" smtClean="0"/>
-              <a:t>01/12/2024</a:t>
+              <a:t>07/01/2025</a:t>
             </a:fld>
             <a:endParaRPr lang="en-GB"/>
           </a:p>
@@ -6006,7 +6007,7 @@
           <a:p>
             <a:fld id="{BA776EC6-7CCE-42A4-93A6-731DCB5BC438}" type="datetimeFigureOut">
               <a:rPr lang="en-GB" smtClean="0"/>
-              <a:t>01/12/2024</a:t>
+              <a:t>07/01/2025</a:t>
             </a:fld>
             <a:endParaRPr lang="en-GB"/>
           </a:p>
@@ -7819,6 +7820,105 @@
           <p:cNvPr id="2" name="Title 1">
             <a:extLst>
               <a:ext uri="{FF2B5EF4-FFF2-40B4-BE49-F238E27FC236}">
+                <a16:creationId xmlns:a16="http://schemas.microsoft.com/office/drawing/2014/main" id="{5FF38D7E-80A4-D4EC-AADA-C540CB31AC83}"/>
+              </a:ext>
+            </a:extLst>
+          </p:cNvPr>
+          <p:cNvSpPr>
+            <a:spLocks noGrp="1"/>
+          </p:cNvSpPr>
+          <p:nvPr>
+            <p:ph type="title"/>
+          </p:nvPr>
+        </p:nvSpPr>
+        <p:spPr>
+          <a:xfrm>
+            <a:off x="646112" y="452718"/>
+            <a:ext cx="8057942" cy="849871"/>
+          </a:xfrm>
+        </p:spPr>
+        <p:txBody>
+          <a:bodyPr/>
+          <a:lstStyle/>
+          <a:p>
+            <a:r>
+              <a:rPr lang="en-US" dirty="0"/>
+              <a:t>Testing with Hardware</a:t>
+            </a:r>
+            <a:endParaRPr lang="en-IE" dirty="0"/>
+          </a:p>
+        </p:txBody>
+      </p:sp>
+      <p:pic>
+        <p:nvPicPr>
+          <p:cNvPr id="5" name="Content Placeholder 4">
+            <a:extLst>
+              <a:ext uri="{FF2B5EF4-FFF2-40B4-BE49-F238E27FC236}">
+                <a16:creationId xmlns:a16="http://schemas.microsoft.com/office/drawing/2014/main" id="{63A17F81-E5C9-ED7D-992A-AE16CD7D5134}"/>
+              </a:ext>
+            </a:extLst>
+          </p:cNvPr>
+          <p:cNvPicPr>
+            <a:picLocks noGrp="1" noChangeAspect="1"/>
+          </p:cNvPicPr>
+          <p:nvPr>
+            <p:ph idx="1"/>
+          </p:nvPr>
+        </p:nvPicPr>
+        <p:blipFill>
+          <a:blip r:embed="rId2">
+            <a:extLst>
+              <a:ext uri="{28A0092B-C50C-407E-A947-70E740481C1C}">
+                <a14:useLocalDpi xmlns:a14="http://schemas.microsoft.com/office/drawing/2010/main" val="0"/>
+              </a:ext>
+            </a:extLst>
+          </a:blip>
+          <a:stretch>
+            <a:fillRect/>
+          </a:stretch>
+        </p:blipFill>
+        <p:spPr>
+          <a:xfrm>
+            <a:off x="2615886" y="1466041"/>
+            <a:ext cx="6960227" cy="5218831"/>
+          </a:xfrm>
+        </p:spPr>
+      </p:pic>
+    </p:spTree>
+    <p:extLst>
+      <p:ext uri="{BB962C8B-B14F-4D97-AF65-F5344CB8AC3E}">
+        <p14:creationId xmlns:p14="http://schemas.microsoft.com/office/powerpoint/2010/main" val="1669427884"/>
+      </p:ext>
+    </p:extLst>
+  </p:cSld>
+  <p:clrMapOvr>
+    <a:masterClrMapping/>
+  </p:clrMapOvr>
+</p:sld>
+</file>
+
+<file path=ppt/slides/slide7.xml><?xml version="1.0" encoding="utf-8"?>
+<p:sld xmlns:a="http://schemas.openxmlformats.org/drawingml/2006/main" xmlns:r="http://schemas.openxmlformats.org/officeDocument/2006/relationships" xmlns:p="http://schemas.openxmlformats.org/presentationml/2006/main">
+  <p:cSld>
+    <p:spTree>
+      <p:nvGrpSpPr>
+        <p:cNvPr id="1" name=""/>
+        <p:cNvGrpSpPr/>
+        <p:nvPr/>
+      </p:nvGrpSpPr>
+      <p:grpSpPr>
+        <a:xfrm>
+          <a:off x="0" y="0"/>
+          <a:ext cx="0" cy="0"/>
+          <a:chOff x="0" y="0"/>
+          <a:chExt cx="0" cy="0"/>
+        </a:xfrm>
+      </p:grpSpPr>
+      <p:sp>
+        <p:nvSpPr>
+          <p:cNvPr id="2" name="Title 1">
+            <a:extLst>
+              <a:ext uri="{FF2B5EF4-FFF2-40B4-BE49-F238E27FC236}">
                 <a16:creationId xmlns:a16="http://schemas.microsoft.com/office/drawing/2014/main" id="{CA30F558-10A3-81FA-D3C9-2F65A26AD791}"/>
               </a:ext>
             </a:extLst>
@@ -7916,7 +8016,7 @@
 </p:sld>
 </file>
 
-<file path=ppt/slides/slide7.xml><?xml version="1.0" encoding="utf-8"?>
+<file path=ppt/slides/slide8.xml><?xml version="1.0" encoding="utf-8"?>
 <p:sld xmlns:a="http://schemas.openxmlformats.org/drawingml/2006/main" xmlns:r="http://schemas.openxmlformats.org/officeDocument/2006/relationships" xmlns:p="http://schemas.openxmlformats.org/presentationml/2006/main">
   <p:cSld>
     <p:spTree>

</xml_diff>